<commit_message>
Corregir la venta de inmuebles: el ITI está derogado
La slide de escalas de Ganancias decía que un inmueble comprado hasta el
31/12/2017 paga ITI del 1,5% sobre el precio de venta. Es incorrecto: el
ITI fue derogado por el artículo 67 de la Ley 27.743, publicada el
8/7/2024, y el escribano ya no retiene por ese concepto.

Hoy esas ventas no tributan. Se mantiene el impuesto cedular del 15%
sobre la ganancia para inmuebles adquiridos desde el 1/1/2018, y la
exención de la casa-habitación.

Co-Authored-By: Claude Opus 5 <noreply@anthropic.com>
Claude-Session: https://claude.ai/code/session_011QVhro7LR9gof15setFRvj
</commit_message>
<xml_diff>
--- a/capacitaciones/impuestos/Capacitacion-Impuestos-Agentes-Inmobiliarios.pptx
+++ b/capacitaciones/impuestos/Capacitacion-Impuestos-Agentes-Inmobiliarios.pptx
@@ -1482,7 +1482,7 @@
           <a:p>
             <a:r>
               <a:rPr lang="en-US" dirty="0"/>
-              <a:t>Ganancias no es una alícuota única, y esa es la confusión más común. En sociedades son tres tramos (25%, 30% y 35%) que se aplican solo sobre el excedente de cada uno, más un 7% si la utilidad se distribuye como dividendo; si se reinvierte, ese 7% no se paga. En personas humanas es una escala de nueve tramos del 5% al 35%. Lo más útil para el equipo es el tercer bloque: al vender un inmueble, la fecha de compra define todo. Hasta el 31/12/2017 corresponde ITI, 1,5% sobre el precio de venta, se haya ganado o perdido. Desde el 1/1/2018 es el impuesto cedular del 15%, pero sobre la ganancia real. Y la casa-habitación —vivienda única de residencia permanente— está exenta en los dos casos. Los montos de los tramos en pesos se actualizan por IPC todos los años, así que nunca hay que citarlos de memoria.</a:t>
+              <a:t>Ganancias no es una alícuota única, y esa es la confusión más común. En sociedades son tres tramos (25%, 30% y 35%) que se aplican solo sobre el excedente de cada uno, más un 7% si la utilidad se distribuye como dividendo; si se reinvierte, ese 7% no se paga. En personas humanas es una escala de nueve tramos del 5% al 35%. Lo más útil para el equipo es el tercer bloque: al vender un inmueble, la fecha de compra define todo. Si se compró hasta el 31/12/2017 hoy no se paga nada: el ITI, que era el 1,5% sobre el precio de venta, fue derogado por el artículo 67 de la Ley 27.743 en julio de 2024, y el escribano ya no retiene por ese concepto. Si se compró desde el 1/1/2018 corresponde el impuesto cedular del 15%, pero sobre la ganancia real, no sobre el precio. Y la casa-habitación —vivienda única de residencia permanente— está exenta del cedular. Los montos de los tramos en pesos se actualizan por IPC todos los años, así que nunca hay que citarlos de memoria.</a:t>
             </a:r>
             <a:endParaRPr lang="en-US" dirty="0"/>
           </a:p>
@@ -13473,7 +13473,7 @@
                 <a:ea typeface="Arial" pitchFamily="34" charset="-122"/>
                 <a:cs typeface="Arial" pitchFamily="34" charset="-120"/>
               </a:rPr>
-              <a:t>ITI</a:t>
+              <a:t>COMPRADO HASTA EL 31/12/2017</a:t>
             </a:r>
             <a:endParaRPr lang="en-US" sz="850" dirty="0"/>
           </a:p>
@@ -13512,7 +13512,7 @@
                 <a:ea typeface="Arial" pitchFamily="34" charset="-122"/>
                 <a:cs typeface="Arial" pitchFamily="34" charset="-120"/>
               </a:rPr>
-              <a:t>1,5%</a:t>
+              <a:t>No paga</a:t>
             </a:r>
             <a:endParaRPr lang="en-US" sz="2000" dirty="0"/>
           </a:p>
@@ -13554,7 +13554,7 @@
                 <a:ea typeface="Arial" pitchFamily="34" charset="-122"/>
                 <a:cs typeface="Arial" pitchFamily="34" charset="-120"/>
               </a:rPr>
-              <a:t>Comprado hasta el 31/12/2017. Se calcula sobre el precio de venta, no sobre la ganancia.</a:t>
+              <a:t>El ITI de 1,5% quedó derogado por la Ley 27.743 en julio de 2024.</a:t>
             </a:r>
             <a:endParaRPr lang="en-US" sz="950" dirty="0"/>
           </a:p>
@@ -13620,7 +13620,7 @@
                 <a:ea typeface="Arial" pitchFamily="34" charset="-122"/>
                 <a:cs typeface="Arial" pitchFamily="34" charset="-120"/>
               </a:rPr>
-              <a:t>IMPUESTO CEDULAR</a:t>
+              <a:t>COMPRADO DESDE EL 1/1/2018</a:t>
             </a:r>
             <a:endParaRPr lang="en-US" sz="850" dirty="0"/>
           </a:p>
@@ -13701,7 +13701,7 @@
                 <a:ea typeface="Arial" pitchFamily="34" charset="-122"/>
                 <a:cs typeface="Arial" pitchFamily="34" charset="-120"/>
               </a:rPr>
-              <a:t>Comprado desde el 1/1/2018. Sobre la ganancia: precio menos costo actualizado y gastos.</a:t>
+              <a:t>Impuesto cedular sobre la ganancia: precio menos costo actualizado y gastos.</a:t>
             </a:r>
             <a:endParaRPr lang="en-US" sz="950" dirty="0"/>
           </a:p>
@@ -13848,7 +13848,7 @@
                 <a:ea typeface="Arial" pitchFamily="34" charset="-122"/>
                 <a:cs typeface="Arial" pitchFamily="34" charset="-120"/>
               </a:rPr>
-              <a:t>La vivienda única de residencia permanente no paga, en ninguno de los dos regímenes.</a:t>
+              <a:t>La vivienda única de residencia permanente no tributa el cedular.</a:t>
             </a:r>
             <a:endParaRPr lang="en-US" sz="950" dirty="0"/>
           </a:p>

</xml_diff>